<commit_message>
feat(slides): add variance & delay comparison for all filter methods
Two new figures (metric_variance, metric_delay) compare RMSE and
effective phase lag across Raw/EMA/Kalman/CNN/GRU/TCN. EMA shows
7 ms lag at tuned α=0.872; neural filters hold to 1 ms while
also cutting RMSE 39% further — motivating the neural approach
on both axes simultaneously.

Adds s08b_variance_delay slide and supporting gen scripts.

Co-Authored-By: Claude Sonnet 4.6 <noreply@anthropic.com>
</commit_message>
<xml_diff>
--- a/presentation.pptx
+++ b/presentation.pptx
@@ -11,6 +11,8 @@
     <p:sldId id="259" r:id="rId10"/>
     <p:sldId id="260" r:id="rId11"/>
     <p:sldId id="261" r:id="rId12"/>
+    <p:sldId id="262" r:id="rId13"/>
+    <p:sldId id="263" r:id="rId14"/>
   </p:sldIdLst>
   <p:sldSz cx="12191695" cy="6858000" type="screen4x3"/>
   <p:notesSz cx="6858000" cy="9144000"/>
@@ -4748,7 +4750,7 @@
                 </a:solidFill>
                 <a:latin typeface="Consolas"/>
               </a:rPr>
-              <a:t>ML2 — METHODS</a:t>
+              <a:t>ML2 — EMA BASELINE: VARIANCE VS DELAY</a:t>
             </a:r>
           </a:p>
         </p:txBody>
@@ -4793,6 +4795,722 @@
                 </a:solidFill>
                 <a:latin typeface="Georgia"/>
               </a:rPr>
+              <a:t>Smoothing always costs delay.</a:t>
+            </a:r>
+          </a:p>
+        </p:txBody>
+      </p:sp>
+      <p:sp>
+        <p:nvSpPr>
+          <p:cNvPr id="6" name="TextBox 5"/>
+          <p:cNvSpPr txBox="1"/>
+          <p:nvPr/>
+        </p:nvSpPr>
+        <p:spPr>
+          <a:xfrm>
+            <a:off x="868680" y="1828800"/>
+            <a:ext cx="10607040" cy="603504"/>
+          </a:xfrm>
+          <a:prstGeom prst="rect">
+            <a:avLst/>
+          </a:prstGeom>
+          <a:noFill/>
+        </p:spPr>
+        <p:txBody>
+          <a:bodyPr wrap="square" anchor="t" lIns="0" rIns="0" tIns="0" bIns="0">
+            <a:spAutoFit/>
+          </a:bodyPr>
+          <a:lstStyle/>
+          <a:p>
+            <a:pPr>
+              <a:lnSpc>
+                <a:spcPct val="120000"/>
+              </a:lnSpc>
+            </a:pPr>
+            <a:r>
+              <a:rPr b="0" sz="1500">
+                <a:solidFill>
+                  <a:srgbClr val="4A5A66"/>
+                </a:solidFill>
+                <a:latin typeface="Calibri"/>
+              </a:rPr>
+              <a:t>The EMA is a causal first-order IIR low-pass filter with a single knob α. Higher α smooths more aggressively (lower output variance) but also pushes the filter's phase lag higher — the two effects are </a:t>
+            </a:r>
+            <a:r>
+              <a:rPr b="1" sz="1500">
+                <a:solidFill>
+                  <a:srgbClr val="1C2B36"/>
+                </a:solidFill>
+                <a:latin typeface="Calibri"/>
+              </a:rPr>
+              <a:t>inseparable</a:t>
+            </a:r>
+            <a:r>
+              <a:rPr b="0" sz="1500">
+                <a:solidFill>
+                  <a:srgbClr val="4A5A66"/>
+                </a:solidFill>
+                <a:latin typeface="Calibri"/>
+              </a:rPr>
+              <a:t>.</a:t>
+            </a:r>
+          </a:p>
+        </p:txBody>
+      </p:sp>
+      <p:sp>
+        <p:nvSpPr>
+          <p:cNvPr id="7" name="Rounded Rectangle 6"/>
+          <p:cNvSpPr/>
+          <p:nvPr/>
+        </p:nvSpPr>
+        <p:spPr>
+          <a:xfrm>
+            <a:off x="868680" y="2743200"/>
+            <a:ext cx="10607040" cy="896112"/>
+          </a:xfrm>
+          <a:prstGeom prst="roundRect">
+            <a:avLst>
+              <a:gd name="adj" fmla="val 6000"/>
+            </a:avLst>
+          </a:prstGeom>
+          <a:solidFill>
+            <a:srgbClr val="F4F1E9"/>
+          </a:solidFill>
+          <a:ln w="12700">
+            <a:solidFill>
+              <a:srgbClr val="D9D2C4"/>
+            </a:solidFill>
+          </a:ln>
+          <a:effectLst/>
+        </p:spPr>
+        <p:style>
+          <a:lnRef idx="1">
+            <a:schemeClr val="accent1"/>
+          </a:lnRef>
+          <a:fillRef idx="3">
+            <a:schemeClr val="accent1"/>
+          </a:fillRef>
+          <a:effectRef idx="2">
+            <a:schemeClr val="accent1"/>
+          </a:effectRef>
+          <a:fontRef idx="minor">
+            <a:schemeClr val="lt1"/>
+          </a:fontRef>
+        </p:style>
+        <p:txBody>
+          <a:bodyPr rtlCol="0" anchor="ctr"/>
+          <a:lstStyle/>
+          <a:p>
+            <a:pPr algn="ctr"/>
+          </a:p>
+        </p:txBody>
+      </p:sp>
+      <p:sp>
+        <p:nvSpPr>
+          <p:cNvPr id="8" name="Rectangle 7"/>
+          <p:cNvSpPr/>
+          <p:nvPr/>
+        </p:nvSpPr>
+        <p:spPr>
+          <a:xfrm>
+            <a:off x="868680" y="2743200"/>
+            <a:ext cx="38100" cy="896112"/>
+          </a:xfrm>
+          <a:prstGeom prst="rect">
+            <a:avLst/>
+          </a:prstGeom>
+          <a:solidFill>
+            <a:srgbClr val="E07A5F"/>
+          </a:solidFill>
+          <a:ln>
+            <a:noFill/>
+          </a:ln>
+          <a:effectLst/>
+        </p:spPr>
+        <p:style>
+          <a:lnRef idx="1">
+            <a:schemeClr val="accent1"/>
+          </a:lnRef>
+          <a:fillRef idx="3">
+            <a:schemeClr val="accent1"/>
+          </a:fillRef>
+          <a:effectRef idx="2">
+            <a:schemeClr val="accent1"/>
+          </a:effectRef>
+          <a:fontRef idx="minor">
+            <a:schemeClr val="lt1"/>
+          </a:fontRef>
+        </p:style>
+        <p:txBody>
+          <a:bodyPr rtlCol="0" anchor="ctr"/>
+          <a:lstStyle/>
+          <a:p>
+            <a:pPr algn="ctr"/>
+          </a:p>
+        </p:txBody>
+      </p:sp>
+      <p:sp>
+        <p:nvSpPr>
+          <p:cNvPr id="9" name="TextBox 8"/>
+          <p:cNvSpPr txBox="1"/>
+          <p:nvPr/>
+        </p:nvSpPr>
+        <p:spPr>
+          <a:xfrm>
+            <a:off x="1069848" y="2852928"/>
+            <a:ext cx="10241280" cy="713232"/>
+          </a:xfrm>
+          <a:prstGeom prst="rect">
+            <a:avLst/>
+          </a:prstGeom>
+          <a:noFill/>
+        </p:spPr>
+        <p:txBody>
+          <a:bodyPr wrap="square" anchor="ctr" lIns="0" rIns="0" tIns="0" bIns="0">
+            <a:spAutoFit/>
+          </a:bodyPr>
+          <a:lstStyle/>
+          <a:p>
+            <a:pPr>
+              <a:lnSpc>
+                <a:spcPct val="115000"/>
+              </a:lnSpc>
+              <a:spcBef>
+                <a:spcPts val="0"/>
+              </a:spcBef>
+              <a:spcAft>
+                <a:spcPts val="0"/>
+              </a:spcAft>
+            </a:pPr>
+            <a:r>
+              <a:rPr b="0" sz="1350">
+                <a:solidFill>
+                  <a:srgbClr val="1D3557"/>
+                </a:solidFill>
+                <a:latin typeface="Consolas"/>
+              </a:rPr>
+              <a:t>y[t]  =  (1 − α)·x[t]  +  α·y[t−1]          H(z) = (1−α) / (1 − αz⁻¹)</a:t>
+            </a:r>
+          </a:p>
+          <a:p>
+            <a:pPr>
+              <a:lnSpc>
+                <a:spcPct val="115000"/>
+              </a:lnSpc>
+              <a:spcBef>
+                <a:spcPts val="400"/>
+              </a:spcBef>
+              <a:spcAft>
+                <a:spcPts val="0"/>
+              </a:spcAft>
+            </a:pPr>
+            <a:r>
+              <a:rPr b="0" sz="1350">
+                <a:solidFill>
+                  <a:srgbClr val="1D3557"/>
+                </a:solidFill>
+                <a:latin typeface="Consolas"/>
+              </a:rPr>
+              <a:t>Var(y)/Var(x) = (1−α)/(1+α)       DC delay = α/(1−α)·dt</a:t>
+            </a:r>
+          </a:p>
+        </p:txBody>
+      </p:sp>
+      <p:sp>
+        <p:nvSpPr>
+          <p:cNvPr id="10" name="Rounded Rectangle 9"/>
+          <p:cNvSpPr/>
+          <p:nvPr/>
+        </p:nvSpPr>
+        <p:spPr>
+          <a:xfrm>
+            <a:off x="868680" y="3858768"/>
+            <a:ext cx="10607040" cy="3172968"/>
+          </a:xfrm>
+          <a:prstGeom prst="roundRect">
+            <a:avLst>
+              <a:gd name="adj" fmla="val 6000"/>
+            </a:avLst>
+          </a:prstGeom>
+          <a:solidFill>
+            <a:srgbClr val="FFFFFF"/>
+          </a:solidFill>
+          <a:ln w="12700">
+            <a:solidFill>
+              <a:srgbClr val="D9D2C4"/>
+            </a:solidFill>
+          </a:ln>
+          <a:effectLst/>
+        </p:spPr>
+        <p:style>
+          <a:lnRef idx="1">
+            <a:schemeClr val="accent1"/>
+          </a:lnRef>
+          <a:fillRef idx="3">
+            <a:schemeClr val="accent1"/>
+          </a:fillRef>
+          <a:effectRef idx="2">
+            <a:schemeClr val="accent1"/>
+          </a:effectRef>
+          <a:fontRef idx="minor">
+            <a:schemeClr val="lt1"/>
+          </a:fontRef>
+        </p:style>
+        <p:txBody>
+          <a:bodyPr rtlCol="0" anchor="ctr"/>
+          <a:lstStyle/>
+          <a:p>
+            <a:pPr algn="ctr"/>
+          </a:p>
+        </p:txBody>
+      </p:sp>
+      <p:pic>
+        <p:nvPicPr>
+          <p:cNvPr id="11" name="Picture 10" descr="ema_properties.png"/>
+          <p:cNvPicPr>
+            <a:picLocks noChangeAspect="1"/>
+          </p:cNvPicPr>
+          <p:nvPr/>
+        </p:nvPicPr>
+        <p:blipFill>
+          <a:blip r:embed="rId2"/>
+          <a:stretch>
+            <a:fillRect/>
+          </a:stretch>
+        </p:blipFill>
+        <p:spPr>
+          <a:xfrm>
+            <a:off x="2853027" y="4005072"/>
+            <a:ext cx="6638346" cy="2423160"/>
+          </a:xfrm>
+          <a:prstGeom prst="rect">
+            <a:avLst/>
+          </a:prstGeom>
+        </p:spPr>
+      </p:pic>
+      <p:sp>
+        <p:nvSpPr>
+          <p:cNvPr id="12" name="TextBox 11"/>
+          <p:cNvSpPr txBox="1"/>
+          <p:nvPr/>
+        </p:nvSpPr>
+        <p:spPr>
+          <a:xfrm>
+            <a:off x="1014984" y="6473952"/>
+            <a:ext cx="10314432" cy="457200"/>
+          </a:xfrm>
+          <a:prstGeom prst="rect">
+            <a:avLst/>
+          </a:prstGeom>
+          <a:noFill/>
+        </p:spPr>
+        <p:txBody>
+          <a:bodyPr wrap="square" anchor="t" lIns="0" rIns="0" tIns="0" bIns="0">
+            <a:spAutoFit/>
+          </a:bodyPr>
+          <a:lstStyle/>
+          <a:p>
+            <a:pPr algn="ctr">
+              <a:lnSpc>
+                <a:spcPct val="110000"/>
+              </a:lnSpc>
+              <a:spcBef>
+                <a:spcPts val="0"/>
+              </a:spcBef>
+              <a:spcAft>
+                <a:spcPts val="600"/>
+              </a:spcAft>
+            </a:pPr>
+            <a:r>
+              <a:rPr b="0" sz="1200">
+                <a:solidFill>
+                  <a:srgbClr val="4A5A66"/>
+                </a:solidFill>
+                <a:latin typeface="Consolas"/>
+              </a:rPr>
+              <a:t>Left: amplitude response |H(f)| — higher α narrows the passband (less noise).  Right: group delay τ(f) — same α inflates lag at every frequency.</a:t>
+            </a:r>
+          </a:p>
+        </p:txBody>
+      </p:sp>
+      <p:sp>
+        <p:nvSpPr>
+          <p:cNvPr id="13" name="Rounded Rectangle 12"/>
+          <p:cNvSpPr/>
+          <p:nvPr/>
+        </p:nvSpPr>
+        <p:spPr>
+          <a:xfrm>
+            <a:off x="868680" y="6263640"/>
+            <a:ext cx="10607040" cy="502920"/>
+          </a:xfrm>
+          <a:prstGeom prst="roundRect">
+            <a:avLst>
+              <a:gd name="adj" fmla="val 6000"/>
+            </a:avLst>
+          </a:prstGeom>
+          <a:solidFill>
+            <a:srgbClr val="FAECE7"/>
+          </a:solidFill>
+          <a:ln w="12700">
+            <a:solidFill>
+              <a:srgbClr val="FAECE7"/>
+            </a:solidFill>
+          </a:ln>
+          <a:effectLst/>
+        </p:spPr>
+        <p:style>
+          <a:lnRef idx="1">
+            <a:schemeClr val="accent1"/>
+          </a:lnRef>
+          <a:fillRef idx="3">
+            <a:schemeClr val="accent1"/>
+          </a:fillRef>
+          <a:effectRef idx="2">
+            <a:schemeClr val="accent1"/>
+          </a:effectRef>
+          <a:fontRef idx="minor">
+            <a:schemeClr val="lt1"/>
+          </a:fontRef>
+        </p:style>
+        <p:txBody>
+          <a:bodyPr rtlCol="0" anchor="ctr"/>
+          <a:lstStyle/>
+          <a:p>
+            <a:pPr algn="ctr"/>
+          </a:p>
+        </p:txBody>
+      </p:sp>
+      <p:sp>
+        <p:nvSpPr>
+          <p:cNvPr id="14" name="Rectangle 13"/>
+          <p:cNvSpPr/>
+          <p:nvPr/>
+        </p:nvSpPr>
+        <p:spPr>
+          <a:xfrm>
+            <a:off x="868680" y="6263640"/>
+            <a:ext cx="38100" cy="502920"/>
+          </a:xfrm>
+          <a:prstGeom prst="rect">
+            <a:avLst/>
+          </a:prstGeom>
+          <a:solidFill>
+            <a:srgbClr val="E07A5F"/>
+          </a:solidFill>
+          <a:ln>
+            <a:noFill/>
+          </a:ln>
+          <a:effectLst/>
+        </p:spPr>
+        <p:style>
+          <a:lnRef idx="1">
+            <a:schemeClr val="accent1"/>
+          </a:lnRef>
+          <a:fillRef idx="3">
+            <a:schemeClr val="accent1"/>
+          </a:fillRef>
+          <a:effectRef idx="2">
+            <a:schemeClr val="accent1"/>
+          </a:effectRef>
+          <a:fontRef idx="minor">
+            <a:schemeClr val="lt1"/>
+          </a:fontRef>
+        </p:style>
+        <p:txBody>
+          <a:bodyPr rtlCol="0" anchor="ctr"/>
+          <a:lstStyle/>
+          <a:p>
+            <a:pPr algn="ctr"/>
+          </a:p>
+        </p:txBody>
+      </p:sp>
+      <p:sp>
+        <p:nvSpPr>
+          <p:cNvPr id="15" name="TextBox 14"/>
+          <p:cNvSpPr txBox="1"/>
+          <p:nvPr/>
+        </p:nvSpPr>
+        <p:spPr>
+          <a:xfrm>
+            <a:off x="1069848" y="6355080"/>
+            <a:ext cx="10222992" cy="320040"/>
+          </a:xfrm>
+          <a:prstGeom prst="rect">
+            <a:avLst/>
+          </a:prstGeom>
+          <a:noFill/>
+        </p:spPr>
+        <p:txBody>
+          <a:bodyPr wrap="square" anchor="ctr" lIns="0" rIns="0" tIns="0" bIns="0">
+            <a:spAutoFit/>
+          </a:bodyPr>
+          <a:lstStyle/>
+          <a:p>
+            <a:pPr>
+              <a:lnSpc>
+                <a:spcPct val="112000"/>
+              </a:lnSpc>
+            </a:pPr>
+            <a:r>
+              <a:rPr b="1" sz="1500">
+                <a:solidFill>
+                  <a:srgbClr val="1D3557"/>
+                </a:solidFill>
+                <a:latin typeface="Georgia"/>
+              </a:rPr>
+              <a:t>Tuned α = 0.872.  </a:t>
+            </a:r>
+            <a:r>
+              <a:rPr b="0" sz="1500">
+                <a:solidFill>
+                  <a:srgbClr val="4A5A66"/>
+                </a:solidFill>
+                <a:latin typeface="Calibri"/>
+              </a:rPr>
+              <a:t>Noise std cut to </a:t>
+            </a:r>
+            <a:r>
+              <a:rPr b="1" sz="1500">
+                <a:solidFill>
+                  <a:srgbClr val="1C2B36"/>
+                </a:solidFill>
+                <a:latin typeface="Calibri"/>
+              </a:rPr>
+              <a:t>~26% of raw</a:t>
+            </a:r>
+            <a:r>
+              <a:rPr b="0" sz="1500">
+                <a:solidFill>
+                  <a:srgbClr val="4A5A66"/>
+                </a:solidFill>
+                <a:latin typeface="Calibri"/>
+              </a:rPr>
+              <a:t> (variance × 0.068) — but at </a:t>
+            </a:r>
+            <a:r>
+              <a:rPr b="1" sz="1500">
+                <a:solidFill>
+                  <a:srgbClr val="1C2B36"/>
+                </a:solidFill>
+                <a:latin typeface="Calibri"/>
+              </a:rPr>
+              <a:t>7 ms DC lag</a:t>
+            </a:r>
+            <a:r>
+              <a:rPr b="0" sz="1500">
+                <a:solidFill>
+                  <a:srgbClr val="4A5A66"/>
+                </a:solidFill>
+                <a:latin typeface="Calibri"/>
+              </a:rPr>
+              <a:t>. Both figures share the same α axis: you cannot get one without paying for the other.</a:t>
+            </a:r>
+          </a:p>
+        </p:txBody>
+      </p:sp>
+    </p:spTree>
+  </p:cSld>
+  <p:clrMapOvr>
+    <a:masterClrMapping/>
+  </p:clrMapOvr>
+</p:sld>
+</file>
+
+<file path=ppt/slides/slide4.xml><?xml version="1.0" encoding="utf-8"?>
+<p:sld xmlns:a="http://schemas.openxmlformats.org/drawingml/2006/main" xmlns:p="http://schemas.openxmlformats.org/presentationml/2006/main" xmlns:r="http://schemas.openxmlformats.org/officeDocument/2006/relationships">
+  <p:cSld>
+    <p:bg>
+      <p:bgPr>
+        <a:solidFill>
+          <a:srgbClr val="FBFAF6"/>
+        </a:solidFill>
+        <a:effectLst/>
+      </p:bgPr>
+    </p:bg>
+    <p:spTree>
+      <p:nvGrpSpPr>
+        <p:cNvPr id="1" name=""/>
+        <p:cNvGrpSpPr/>
+        <p:nvPr/>
+      </p:nvGrpSpPr>
+      <p:grpSpPr/>
+      <p:sp>
+        <p:nvSpPr>
+          <p:cNvPr id="2" name="Rectangle 1"/>
+          <p:cNvSpPr/>
+          <p:nvPr/>
+        </p:nvSpPr>
+        <p:spPr>
+          <a:xfrm>
+            <a:off x="566928" y="502920"/>
+            <a:ext cx="17780" cy="5852160"/>
+          </a:xfrm>
+          <a:prstGeom prst="rect">
+            <a:avLst/>
+          </a:prstGeom>
+          <a:solidFill>
+            <a:srgbClr val="D9D2C4"/>
+          </a:solidFill>
+          <a:ln>
+            <a:noFill/>
+          </a:ln>
+          <a:effectLst/>
+        </p:spPr>
+        <p:style>
+          <a:lnRef idx="1">
+            <a:schemeClr val="accent1"/>
+          </a:lnRef>
+          <a:fillRef idx="3">
+            <a:schemeClr val="accent1"/>
+          </a:fillRef>
+          <a:effectRef idx="2">
+            <a:schemeClr val="accent1"/>
+          </a:effectRef>
+          <a:fontRef idx="minor">
+            <a:schemeClr val="lt1"/>
+          </a:fontRef>
+        </p:style>
+        <p:txBody>
+          <a:bodyPr rtlCol="0" anchor="ctr"/>
+          <a:lstStyle/>
+          <a:p>
+            <a:pPr algn="ctr"/>
+          </a:p>
+        </p:txBody>
+      </p:sp>
+      <p:sp>
+        <p:nvSpPr>
+          <p:cNvPr id="3" name="Rectangle 2"/>
+          <p:cNvSpPr/>
+          <p:nvPr/>
+        </p:nvSpPr>
+        <p:spPr>
+          <a:xfrm>
+            <a:off x="566928" y="502920"/>
+            <a:ext cx="30480" cy="566928"/>
+          </a:xfrm>
+          <a:prstGeom prst="rect">
+            <a:avLst/>
+          </a:prstGeom>
+          <a:solidFill>
+            <a:srgbClr val="2A9D8F"/>
+          </a:solidFill>
+          <a:ln>
+            <a:noFill/>
+          </a:ln>
+          <a:effectLst/>
+        </p:spPr>
+        <p:style>
+          <a:lnRef idx="1">
+            <a:schemeClr val="accent1"/>
+          </a:lnRef>
+          <a:fillRef idx="3">
+            <a:schemeClr val="accent1"/>
+          </a:fillRef>
+          <a:effectRef idx="2">
+            <a:schemeClr val="accent1"/>
+          </a:effectRef>
+          <a:fontRef idx="minor">
+            <a:schemeClr val="lt1"/>
+          </a:fontRef>
+        </p:style>
+        <p:txBody>
+          <a:bodyPr rtlCol="0" anchor="ctr"/>
+          <a:lstStyle/>
+          <a:p>
+            <a:pPr algn="ctr"/>
+          </a:p>
+        </p:txBody>
+      </p:sp>
+      <p:sp>
+        <p:nvSpPr>
+          <p:cNvPr id="4" name="TextBox 3"/>
+          <p:cNvSpPr txBox="1"/>
+          <p:nvPr/>
+        </p:nvSpPr>
+        <p:spPr>
+          <a:xfrm>
+            <a:off x="868680" y="548640"/>
+            <a:ext cx="10607040" cy="320040"/>
+          </a:xfrm>
+          <a:prstGeom prst="rect">
+            <a:avLst/>
+          </a:prstGeom>
+          <a:noFill/>
+        </p:spPr>
+        <p:txBody>
+          <a:bodyPr wrap="square" anchor="t" lIns="0" rIns="0" tIns="0" bIns="0">
+            <a:spAutoFit/>
+          </a:bodyPr>
+          <a:lstStyle/>
+          <a:p>
+            <a:pPr>
+              <a:lnSpc>
+                <a:spcPct val="100000"/>
+              </a:lnSpc>
+            </a:pPr>
+            <a:r>
+              <a:rPr sz="1100" b="1">
+                <a:solidFill>
+                  <a:srgbClr val="E07A5F"/>
+                </a:solidFill>
+                <a:latin typeface="Consolas"/>
+              </a:rPr>
+              <a:t>04  </a:t>
+            </a:r>
+            <a:r>
+              <a:rPr sz="1100">
+                <a:solidFill>
+                  <a:srgbClr val="2A9D8F"/>
+                </a:solidFill>
+                <a:latin typeface="Consolas"/>
+              </a:rPr>
+              <a:t>ML2 — METHODS</a:t>
+            </a:r>
+          </a:p>
+        </p:txBody>
+      </p:sp>
+      <p:sp>
+        <p:nvSpPr>
+          <p:cNvPr id="5" name="TextBox 4"/>
+          <p:cNvSpPr txBox="1"/>
+          <p:nvPr/>
+        </p:nvSpPr>
+        <p:spPr>
+          <a:xfrm>
+            <a:off x="868680" y="960120"/>
+            <a:ext cx="10607040" cy="1280160"/>
+          </a:xfrm>
+          <a:prstGeom prst="rect">
+            <a:avLst/>
+          </a:prstGeom>
+          <a:noFill/>
+        </p:spPr>
+        <p:txBody>
+          <a:bodyPr wrap="square" anchor="t" lIns="0" rIns="0" tIns="0" bIns="0">
+            <a:spAutoFit/>
+          </a:bodyPr>
+          <a:lstStyle/>
+          <a:p>
+            <a:pPr algn="l">
+              <a:lnSpc>
+                <a:spcPct val="102000"/>
+              </a:lnSpc>
+              <a:spcBef>
+                <a:spcPts val="0"/>
+              </a:spcBef>
+              <a:spcAft>
+                <a:spcPts val="600"/>
+              </a:spcAft>
+            </a:pPr>
+            <a:r>
+              <a:rPr b="1" sz="2800">
+                <a:solidFill>
+                  <a:srgbClr val="1D3557"/>
+                </a:solidFill>
+                <a:latin typeface="Georgia"/>
+              </a:rPr>
               <a:t>Classical baselines vs learned filters.</a:t>
             </a:r>
           </a:p>
@@ -5673,7 +6391,7 @@
 </p:sld>
 </file>
 
-<file path=ppt/slides/slide4.xml><?xml version="1.0" encoding="utf-8"?>
+<file path=ppt/slides/slide5.xml><?xml version="1.0" encoding="utf-8"?>
 <p:sld xmlns:a="http://schemas.openxmlformats.org/drawingml/2006/main" xmlns:p="http://schemas.openxmlformats.org/presentationml/2006/main" xmlns:r="http://schemas.openxmlformats.org/officeDocument/2006/relationships">
   <p:cSld>
     <p:bg>
@@ -6412,7 +7130,7 @@
 </p:sld>
 </file>
 
-<file path=ppt/slides/slide5.xml><?xml version="1.0" encoding="utf-8"?>
+<file path=ppt/slides/slide6.xml><?xml version="1.0" encoding="utf-8"?>
 <p:sld xmlns:a="http://schemas.openxmlformats.org/drawingml/2006/main" xmlns:p="http://schemas.openxmlformats.org/presentationml/2006/main" xmlns:r="http://schemas.openxmlformats.org/officeDocument/2006/relationships">
   <p:cSld>
     <p:bg>
@@ -6897,7 +7615,654 @@
 </p:sld>
 </file>
 
-<file path=ppt/slides/slide6.xml><?xml version="1.0" encoding="utf-8"?>
+<file path=ppt/slides/slide7.xml><?xml version="1.0" encoding="utf-8"?>
+<p:sld xmlns:a="http://schemas.openxmlformats.org/drawingml/2006/main" xmlns:p="http://schemas.openxmlformats.org/presentationml/2006/main" xmlns:r="http://schemas.openxmlformats.org/officeDocument/2006/relationships">
+  <p:cSld>
+    <p:bg>
+      <p:bgPr>
+        <a:solidFill>
+          <a:srgbClr val="FBFAF6"/>
+        </a:solidFill>
+        <a:effectLst/>
+      </p:bgPr>
+    </p:bg>
+    <p:spTree>
+      <p:nvGrpSpPr>
+        <p:cNvPr id="1" name=""/>
+        <p:cNvGrpSpPr/>
+        <p:nvPr/>
+      </p:nvGrpSpPr>
+      <p:grpSpPr/>
+      <p:sp>
+        <p:nvSpPr>
+          <p:cNvPr id="2" name="Rectangle 1"/>
+          <p:cNvSpPr/>
+          <p:nvPr/>
+        </p:nvSpPr>
+        <p:spPr>
+          <a:xfrm>
+            <a:off x="566928" y="502920"/>
+            <a:ext cx="17780" cy="5852160"/>
+          </a:xfrm>
+          <a:prstGeom prst="rect">
+            <a:avLst/>
+          </a:prstGeom>
+          <a:solidFill>
+            <a:srgbClr val="D9D2C4"/>
+          </a:solidFill>
+          <a:ln>
+            <a:noFill/>
+          </a:ln>
+          <a:effectLst/>
+        </p:spPr>
+        <p:style>
+          <a:lnRef idx="1">
+            <a:schemeClr val="accent1"/>
+          </a:lnRef>
+          <a:fillRef idx="3">
+            <a:schemeClr val="accent1"/>
+          </a:fillRef>
+          <a:effectRef idx="2">
+            <a:schemeClr val="accent1"/>
+          </a:effectRef>
+          <a:fontRef idx="minor">
+            <a:schemeClr val="lt1"/>
+          </a:fontRef>
+        </p:style>
+        <p:txBody>
+          <a:bodyPr rtlCol="0" anchor="ctr"/>
+          <a:lstStyle/>
+          <a:p>
+            <a:pPr algn="ctr"/>
+          </a:p>
+        </p:txBody>
+      </p:sp>
+      <p:sp>
+        <p:nvSpPr>
+          <p:cNvPr id="3" name="Rectangle 2"/>
+          <p:cNvSpPr/>
+          <p:nvPr/>
+        </p:nvSpPr>
+        <p:spPr>
+          <a:xfrm>
+            <a:off x="566928" y="502920"/>
+            <a:ext cx="30480" cy="566928"/>
+          </a:xfrm>
+          <a:prstGeom prst="rect">
+            <a:avLst/>
+          </a:prstGeom>
+          <a:solidFill>
+            <a:srgbClr val="2A9D8F"/>
+          </a:solidFill>
+          <a:ln>
+            <a:noFill/>
+          </a:ln>
+          <a:effectLst/>
+        </p:spPr>
+        <p:style>
+          <a:lnRef idx="1">
+            <a:schemeClr val="accent1"/>
+          </a:lnRef>
+          <a:fillRef idx="3">
+            <a:schemeClr val="accent1"/>
+          </a:fillRef>
+          <a:effectRef idx="2">
+            <a:schemeClr val="accent1"/>
+          </a:effectRef>
+          <a:fontRef idx="minor">
+            <a:schemeClr val="lt1"/>
+          </a:fontRef>
+        </p:style>
+        <p:txBody>
+          <a:bodyPr rtlCol="0" anchor="ctr"/>
+          <a:lstStyle/>
+          <a:p>
+            <a:pPr algn="ctr"/>
+          </a:p>
+        </p:txBody>
+      </p:sp>
+      <p:sp>
+        <p:nvSpPr>
+          <p:cNvPr id="4" name="TextBox 3"/>
+          <p:cNvSpPr txBox="1"/>
+          <p:nvPr/>
+        </p:nvSpPr>
+        <p:spPr>
+          <a:xfrm>
+            <a:off x="868680" y="548640"/>
+            <a:ext cx="10607040" cy="320040"/>
+          </a:xfrm>
+          <a:prstGeom prst="rect">
+            <a:avLst/>
+          </a:prstGeom>
+          <a:noFill/>
+        </p:spPr>
+        <p:txBody>
+          <a:bodyPr wrap="square" anchor="t" lIns="0" rIns="0" tIns="0" bIns="0">
+            <a:spAutoFit/>
+          </a:bodyPr>
+          <a:lstStyle/>
+          <a:p>
+            <a:pPr>
+              <a:lnSpc>
+                <a:spcPct val="100000"/>
+              </a:lnSpc>
+            </a:pPr>
+            <a:r>
+              <a:rPr sz="1100" b="1">
+                <a:solidFill>
+                  <a:srgbClr val="E07A5F"/>
+                </a:solidFill>
+                <a:latin typeface="Consolas"/>
+              </a:rPr>
+              <a:t>06b  </a:t>
+            </a:r>
+            <a:r>
+              <a:rPr sz="1100">
+                <a:solidFill>
+                  <a:srgbClr val="2A9D8F"/>
+                </a:solidFill>
+                <a:latin typeface="Consolas"/>
+              </a:rPr>
+              <a:t>ML2 — RESULTS: VARIANCE &amp; DELAY</a:t>
+            </a:r>
+          </a:p>
+        </p:txBody>
+      </p:sp>
+      <p:sp>
+        <p:nvSpPr>
+          <p:cNvPr id="5" name="TextBox 4"/>
+          <p:cNvSpPr txBox="1"/>
+          <p:nvPr/>
+        </p:nvSpPr>
+        <p:spPr>
+          <a:xfrm>
+            <a:off x="868680" y="960120"/>
+            <a:ext cx="10607040" cy="1280160"/>
+          </a:xfrm>
+          <a:prstGeom prst="rect">
+            <a:avLst/>
+          </a:prstGeom>
+          <a:noFill/>
+        </p:spPr>
+        <p:txBody>
+          <a:bodyPr wrap="square" anchor="t" lIns="0" rIns="0" tIns="0" bIns="0">
+            <a:spAutoFit/>
+          </a:bodyPr>
+          <a:lstStyle/>
+          <a:p>
+            <a:pPr algn="l">
+              <a:lnSpc>
+                <a:spcPct val="102000"/>
+              </a:lnSpc>
+              <a:spcBef>
+                <a:spcPts val="0"/>
+              </a:spcBef>
+              <a:spcAft>
+                <a:spcPts val="600"/>
+              </a:spcAft>
+            </a:pPr>
+            <a:r>
+              <a:rPr b="1" sz="2800">
+                <a:solidFill>
+                  <a:srgbClr val="1D3557"/>
+                </a:solidFill>
+                <a:latin typeface="Georgia"/>
+              </a:rPr>
+              <a:t>Neural filters win on both axes.</a:t>
+            </a:r>
+          </a:p>
+        </p:txBody>
+      </p:sp>
+      <p:sp>
+        <p:nvSpPr>
+          <p:cNvPr id="6" name="TextBox 5"/>
+          <p:cNvSpPr txBox="1"/>
+          <p:nvPr/>
+        </p:nvSpPr>
+        <p:spPr>
+          <a:xfrm>
+            <a:off x="868680" y="1828800"/>
+            <a:ext cx="10607040" cy="502920"/>
+          </a:xfrm>
+          <a:prstGeom prst="rect">
+            <a:avLst/>
+          </a:prstGeom>
+          <a:noFill/>
+        </p:spPr>
+        <p:txBody>
+          <a:bodyPr wrap="square" anchor="t" lIns="0" rIns="0" tIns="0" bIns="0">
+            <a:spAutoFit/>
+          </a:bodyPr>
+          <a:lstStyle/>
+          <a:p>
+            <a:pPr>
+              <a:lnSpc>
+                <a:spcPct val="120000"/>
+              </a:lnSpc>
+            </a:pPr>
+            <a:r>
+              <a:rPr b="0" sz="1500">
+                <a:solidFill>
+                  <a:srgbClr val="4A5A66"/>
+                </a:solidFill>
+                <a:latin typeface="Calibri"/>
+              </a:rPr>
+              <a:t>Variance (RMSE) and phase lag (effective delay) are </a:t>
+            </a:r>
+            <a:r>
+              <a:rPr b="1" sz="1500">
+                <a:solidFill>
+                  <a:srgbClr val="1C2B36"/>
+                </a:solidFill>
+                <a:latin typeface="Calibri"/>
+              </a:rPr>
+              <a:t>independent failure modes</a:t>
+            </a:r>
+            <a:r>
+              <a:rPr b="0" sz="1500">
+                <a:solidFill>
+                  <a:srgbClr val="4A5A66"/>
+                </a:solidFill>
+                <a:latin typeface="Calibri"/>
+              </a:rPr>
+              <a:t>. A good filter must minimize both — not just one.</a:t>
+            </a:r>
+          </a:p>
+        </p:txBody>
+      </p:sp>
+      <p:sp>
+        <p:nvSpPr>
+          <p:cNvPr id="7" name="Rounded Rectangle 6"/>
+          <p:cNvSpPr/>
+          <p:nvPr/>
+        </p:nvSpPr>
+        <p:spPr>
+          <a:xfrm>
+            <a:off x="868680" y="2514600"/>
+            <a:ext cx="5166360" cy="3640101"/>
+          </a:xfrm>
+          <a:prstGeom prst="roundRect">
+            <a:avLst>
+              <a:gd name="adj" fmla="val 6000"/>
+            </a:avLst>
+          </a:prstGeom>
+          <a:solidFill>
+            <a:srgbClr val="FFFFFF"/>
+          </a:solidFill>
+          <a:ln w="12700">
+            <a:solidFill>
+              <a:srgbClr val="D9D2C4"/>
+            </a:solidFill>
+          </a:ln>
+          <a:effectLst/>
+        </p:spPr>
+        <p:style>
+          <a:lnRef idx="1">
+            <a:schemeClr val="accent1"/>
+          </a:lnRef>
+          <a:fillRef idx="3">
+            <a:schemeClr val="accent1"/>
+          </a:fillRef>
+          <a:effectRef idx="2">
+            <a:schemeClr val="accent1"/>
+          </a:effectRef>
+          <a:fontRef idx="minor">
+            <a:schemeClr val="lt1"/>
+          </a:fontRef>
+        </p:style>
+        <p:txBody>
+          <a:bodyPr rtlCol="0" anchor="ctr"/>
+          <a:lstStyle/>
+          <a:p>
+            <a:pPr algn="ctr"/>
+          </a:p>
+        </p:txBody>
+      </p:sp>
+      <p:pic>
+        <p:nvPicPr>
+          <p:cNvPr id="8" name="Picture 7" descr="metric_variance.png"/>
+          <p:cNvPicPr>
+            <a:picLocks noChangeAspect="1"/>
+          </p:cNvPicPr>
+          <p:nvPr/>
+        </p:nvPicPr>
+        <p:blipFill>
+          <a:blip r:embed="rId2"/>
+          <a:stretch>
+            <a:fillRect/>
+          </a:stretch>
+        </p:blipFill>
+        <p:spPr>
+          <a:xfrm>
+            <a:off x="1014984" y="2660904"/>
+            <a:ext cx="4873752" cy="2890293"/>
+          </a:xfrm>
+          <a:prstGeom prst="rect">
+            <a:avLst/>
+          </a:prstGeom>
+        </p:spPr>
+      </p:pic>
+      <p:sp>
+        <p:nvSpPr>
+          <p:cNvPr id="9" name="TextBox 8"/>
+          <p:cNvSpPr txBox="1"/>
+          <p:nvPr/>
+        </p:nvSpPr>
+        <p:spPr>
+          <a:xfrm>
+            <a:off x="1014984" y="5596917"/>
+            <a:ext cx="4873752" cy="457200"/>
+          </a:xfrm>
+          <a:prstGeom prst="rect">
+            <a:avLst/>
+          </a:prstGeom>
+          <a:noFill/>
+        </p:spPr>
+        <p:txBody>
+          <a:bodyPr wrap="square" anchor="t" lIns="0" rIns="0" tIns="0" bIns="0">
+            <a:spAutoFit/>
+          </a:bodyPr>
+          <a:lstStyle/>
+          <a:p>
+            <a:pPr algn="ctr">
+              <a:lnSpc>
+                <a:spcPct val="110000"/>
+              </a:lnSpc>
+              <a:spcBef>
+                <a:spcPts val="0"/>
+              </a:spcBef>
+              <a:spcAft>
+                <a:spcPts val="600"/>
+              </a:spcAft>
+            </a:pPr>
+            <a:r>
+              <a:rPr b="0" sz="1200">
+                <a:solidFill>
+                  <a:srgbClr val="4A5A66"/>
+                </a:solidFill>
+                <a:latin typeface="Consolas"/>
+              </a:rPr>
+              <a:t>Error std (RMSE, rad/s) — lower is better</a:t>
+            </a:r>
+          </a:p>
+        </p:txBody>
+      </p:sp>
+      <p:sp>
+        <p:nvSpPr>
+          <p:cNvPr id="10" name="Rounded Rectangle 9"/>
+          <p:cNvSpPr/>
+          <p:nvPr/>
+        </p:nvSpPr>
+        <p:spPr>
+          <a:xfrm>
+            <a:off x="6309360" y="2514600"/>
+            <a:ext cx="5166360" cy="3640101"/>
+          </a:xfrm>
+          <a:prstGeom prst="roundRect">
+            <a:avLst>
+              <a:gd name="adj" fmla="val 6000"/>
+            </a:avLst>
+          </a:prstGeom>
+          <a:solidFill>
+            <a:srgbClr val="FFFFFF"/>
+          </a:solidFill>
+          <a:ln w="12700">
+            <a:solidFill>
+              <a:srgbClr val="D9D2C4"/>
+            </a:solidFill>
+          </a:ln>
+          <a:effectLst/>
+        </p:spPr>
+        <p:style>
+          <a:lnRef idx="1">
+            <a:schemeClr val="accent1"/>
+          </a:lnRef>
+          <a:fillRef idx="3">
+            <a:schemeClr val="accent1"/>
+          </a:fillRef>
+          <a:effectRef idx="2">
+            <a:schemeClr val="accent1"/>
+          </a:effectRef>
+          <a:fontRef idx="minor">
+            <a:schemeClr val="lt1"/>
+          </a:fontRef>
+        </p:style>
+        <p:txBody>
+          <a:bodyPr rtlCol="0" anchor="ctr"/>
+          <a:lstStyle/>
+          <a:p>
+            <a:pPr algn="ctr"/>
+          </a:p>
+        </p:txBody>
+      </p:sp>
+      <p:pic>
+        <p:nvPicPr>
+          <p:cNvPr id="11" name="Picture 10" descr="metric_delay.png"/>
+          <p:cNvPicPr>
+            <a:picLocks noChangeAspect="1"/>
+          </p:cNvPicPr>
+          <p:nvPr/>
+        </p:nvPicPr>
+        <p:blipFill>
+          <a:blip r:embed="rId3"/>
+          <a:stretch>
+            <a:fillRect/>
+          </a:stretch>
+        </p:blipFill>
+        <p:spPr>
+          <a:xfrm>
+            <a:off x="6455664" y="2660904"/>
+            <a:ext cx="4873752" cy="2890293"/>
+          </a:xfrm>
+          <a:prstGeom prst="rect">
+            <a:avLst/>
+          </a:prstGeom>
+        </p:spPr>
+      </p:pic>
+      <p:sp>
+        <p:nvSpPr>
+          <p:cNvPr id="12" name="TextBox 11"/>
+          <p:cNvSpPr txBox="1"/>
+          <p:nvPr/>
+        </p:nvSpPr>
+        <p:spPr>
+          <a:xfrm>
+            <a:off x="6455664" y="5596917"/>
+            <a:ext cx="4873752" cy="457200"/>
+          </a:xfrm>
+          <a:prstGeom prst="rect">
+            <a:avLst/>
+          </a:prstGeom>
+          <a:noFill/>
+        </p:spPr>
+        <p:txBody>
+          <a:bodyPr wrap="square" anchor="t" lIns="0" rIns="0" tIns="0" bIns="0">
+            <a:spAutoFit/>
+          </a:bodyPr>
+          <a:lstStyle/>
+          <a:p>
+            <a:pPr algn="ctr">
+              <a:lnSpc>
+                <a:spcPct val="110000"/>
+              </a:lnSpc>
+              <a:spcBef>
+                <a:spcPts val="0"/>
+              </a:spcBef>
+              <a:spcAft>
+                <a:spcPts val="600"/>
+              </a:spcAft>
+            </a:pPr>
+            <a:r>
+              <a:rPr b="0" sz="1200">
+                <a:solidFill>
+                  <a:srgbClr val="4A5A66"/>
+                </a:solidFill>
+                <a:latin typeface="Consolas"/>
+              </a:rPr>
+              <a:t>Effective phase lag (ms) — lower is better</a:t>
+            </a:r>
+          </a:p>
+        </p:txBody>
+      </p:sp>
+      <p:sp>
+        <p:nvSpPr>
+          <p:cNvPr id="13" name="Rounded Rectangle 12"/>
+          <p:cNvSpPr/>
+          <p:nvPr/>
+        </p:nvSpPr>
+        <p:spPr>
+          <a:xfrm>
+            <a:off x="868680" y="6035040"/>
+            <a:ext cx="10607040" cy="749808"/>
+          </a:xfrm>
+          <a:prstGeom prst="roundRect">
+            <a:avLst>
+              <a:gd name="adj" fmla="val 6000"/>
+            </a:avLst>
+          </a:prstGeom>
+          <a:solidFill>
+            <a:srgbClr val="E7F2F0"/>
+          </a:solidFill>
+          <a:ln w="12700">
+            <a:solidFill>
+              <a:srgbClr val="E7F2F0"/>
+            </a:solidFill>
+          </a:ln>
+          <a:effectLst/>
+        </p:spPr>
+        <p:style>
+          <a:lnRef idx="1">
+            <a:schemeClr val="accent1"/>
+          </a:lnRef>
+          <a:fillRef idx="3">
+            <a:schemeClr val="accent1"/>
+          </a:fillRef>
+          <a:effectRef idx="2">
+            <a:schemeClr val="accent1"/>
+          </a:effectRef>
+          <a:fontRef idx="minor">
+            <a:schemeClr val="lt1"/>
+          </a:fontRef>
+        </p:style>
+        <p:txBody>
+          <a:bodyPr rtlCol="0" anchor="ctr"/>
+          <a:lstStyle/>
+          <a:p>
+            <a:pPr algn="ctr"/>
+          </a:p>
+        </p:txBody>
+      </p:sp>
+      <p:sp>
+        <p:nvSpPr>
+          <p:cNvPr id="14" name="Rectangle 13"/>
+          <p:cNvSpPr/>
+          <p:nvPr/>
+        </p:nvSpPr>
+        <p:spPr>
+          <a:xfrm>
+            <a:off x="868680" y="6035040"/>
+            <a:ext cx="38100" cy="749808"/>
+          </a:xfrm>
+          <a:prstGeom prst="rect">
+            <a:avLst/>
+          </a:prstGeom>
+          <a:solidFill>
+            <a:srgbClr val="2A9D8F"/>
+          </a:solidFill>
+          <a:ln>
+            <a:noFill/>
+          </a:ln>
+          <a:effectLst/>
+        </p:spPr>
+        <p:style>
+          <a:lnRef idx="1">
+            <a:schemeClr val="accent1"/>
+          </a:lnRef>
+          <a:fillRef idx="3">
+            <a:schemeClr val="accent1"/>
+          </a:fillRef>
+          <a:effectRef idx="2">
+            <a:schemeClr val="accent1"/>
+          </a:effectRef>
+          <a:fontRef idx="minor">
+            <a:schemeClr val="lt1"/>
+          </a:fontRef>
+        </p:style>
+        <p:txBody>
+          <a:bodyPr rtlCol="0" anchor="ctr"/>
+          <a:lstStyle/>
+          <a:p>
+            <a:pPr algn="ctr"/>
+          </a:p>
+        </p:txBody>
+      </p:sp>
+      <p:sp>
+        <p:nvSpPr>
+          <p:cNvPr id="15" name="TextBox 14"/>
+          <p:cNvSpPr txBox="1"/>
+          <p:nvPr/>
+        </p:nvSpPr>
+        <p:spPr>
+          <a:xfrm>
+            <a:off x="1069848" y="6126480"/>
+            <a:ext cx="10222992" cy="566928"/>
+          </a:xfrm>
+          <a:prstGeom prst="rect">
+            <a:avLst/>
+          </a:prstGeom>
+          <a:noFill/>
+        </p:spPr>
+        <p:txBody>
+          <a:bodyPr wrap="square" anchor="ctr" lIns="0" rIns="0" tIns="0" bIns="0">
+            <a:spAutoFit/>
+          </a:bodyPr>
+          <a:lstStyle/>
+          <a:p>
+            <a:pPr>
+              <a:lnSpc>
+                <a:spcPct val="112000"/>
+              </a:lnSpc>
+            </a:pPr>
+            <a:r>
+              <a:rPr b="1" sz="1500">
+                <a:solidFill>
+                  <a:srgbClr val="1D3557"/>
+                </a:solidFill>
+                <a:latin typeface="Georgia"/>
+              </a:rPr>
+              <a:t>EMA: 7 ms lag, GRU/TCN: 1 ms.  </a:t>
+            </a:r>
+            <a:r>
+              <a:rPr b="1" sz="1500">
+                <a:solidFill>
+                  <a:srgbClr val="1C2B36"/>
+                </a:solidFill>
+                <a:latin typeface="Calibri"/>
+              </a:rPr>
+              <a:t>EMA halves RMSE vs raw but costs 7 ms of lag</a:t>
+            </a:r>
+            <a:r>
+              <a:rPr b="0" sz="1500">
+                <a:solidFill>
+                  <a:srgbClr val="4A5A66"/>
+                </a:solidFill>
+                <a:latin typeface="Calibri"/>
+              </a:rPr>
+              <a:t> at α = 0.872. Neural filters cut RMSE a further 39 % AND reduce lag to one sample — faster response, less noise.</a:t>
+            </a:r>
+          </a:p>
+        </p:txBody>
+      </p:sp>
+    </p:spTree>
+  </p:cSld>
+  <p:clrMapOvr>
+    <a:masterClrMapping/>
+  </p:clrMapOvr>
+</p:sld>
+</file>
+
+<file path=ppt/slides/slide8.xml><?xml version="1.0" encoding="utf-8"?>
 <p:sld xmlns:a="http://schemas.openxmlformats.org/drawingml/2006/main" xmlns:p="http://schemas.openxmlformats.org/presentationml/2006/main" xmlns:r="http://schemas.openxmlformats.org/officeDocument/2006/relationships">
   <p:cSld>
     <p:bg>

</xml_diff>